<commit_message>
Tiering: any single 100%-accuracy hard-rule hit → T1
Per product decision, a hit on any one of the four Accuracy=100%
deterministic hard rules now goes straight to T1 (was >=2). T2 is
redefined as "vendor-level behavioral signal only" (no hard hit);
T3 unchanged. Updated the tiering-logic slide (S4) and aligned the
core-shift problem wording (S3) in both EN and CN decks.

Note: decks now describe T1=>=1 hit; the demo HTML still uses >=2 for
T1 — to be synced separately if desired.

Co-Authored-By: Claude Opus 4.8 (1M context) <noreply@anthropic.com>
</commit_message>
<xml_diff>
--- a/ppt/AML-System-Walkthrough-Legal-CN.pptx
+++ b/ppt/AML-System-Walkthrough-Legal-CN.pptx
@@ -2963,7 +2963,7 @@
                 <a:ea typeface="Microsoft YaHei" pitchFamily="34" charset="-122"/>
                 <a:cs typeface="Microsoft YaHei" pitchFamily="34" charset="-120"/>
               </a:rPr>
-              <a:t>强信号被「平均」稀释：一笔命中 2 条 30% 命中率硬规则的付款，被其它正常维度一平均就沉底、可能没人看。</a:t>
+              <a:t>强信号被「平均」稀释：一笔哪怕只命中 1 条 30% 命中率硬规则的付款，被其它正常维度一平均就沉底、可能没人看。</a:t>
             </a:r>
             <a:endParaRPr lang="en-US" sz="1250" dirty="0"/>
           </a:p>
@@ -3609,7 +3609,7 @@
                 <a:ea typeface="Microsoft YaHei" pitchFamily="34" charset="-122"/>
                 <a:cs typeface="Microsoft YaHei" pitchFamily="34" charset="-120"/>
               </a:rPr>
-              <a:t>分级逻辑：看命中几条高精度规则</a:t>
+              <a:t>分级逻辑：命中任意一条高精度规则即 T1</a:t>
             </a:r>
             <a:endParaRPr lang="en-US" sz="3000" dirty="0"/>
           </a:p>
@@ -3682,7 +3682,7 @@
                 <a:ea typeface="Microsoft YaHei" pitchFamily="34" charset="-122"/>
                 <a:cs typeface="Microsoft YaHei" pitchFamily="34" charset="-120"/>
               </a:rPr>
-              <a:t>付款级高精度规则（入口 A）</a:t>
+              <a:t>付款级硬规则（入口 A）</a:t>
             </a:r>
             <a:endParaRPr lang="en-US" sz="1600" dirty="0"/>
           </a:p>
@@ -3721,7 +3721,7 @@
                 <a:ea typeface="Microsoft YaHei" pitchFamily="34" charset="-122"/>
                 <a:cs typeface="Microsoft YaHei" pitchFamily="34" charset="-120"/>
               </a:rPr>
-              <a:t>每条约 30% PPV —— 命中后约三成确实是洗钱</a:t>
+              <a:t>准确率 100% 的确定性校验 —— 单条命中即高置信</a:t>
             </a:r>
             <a:endParaRPr lang="en-US" sz="1150" dirty="0"/>
           </a:p>
@@ -3955,7 +3955,7 @@
                 <a:ea typeface="Microsoft YaHei" pitchFamily="34" charset="-122"/>
                 <a:cs typeface="Microsoft YaHei" pitchFamily="34" charset="-120"/>
               </a:rPr>
-              <a:t>命中 ≥ 2 条高精度规则</a:t>
+              <a:t>命中任意 1 条高精度规则</a:t>
             </a:r>
             <a:endParaRPr lang="en-US" sz="1500" dirty="0"/>
           </a:p>
@@ -4110,7 +4110,7 @@
                 <a:ea typeface="Microsoft YaHei" pitchFamily="34" charset="-122"/>
                 <a:cs typeface="Microsoft YaHei" pitchFamily="34" charset="-120"/>
               </a:rPr>
-              <a:t>命中 1 条高精度规则</a:t>
+              <a:t>仅命中供应商级信号</a:t>
             </a:r>
             <a:endParaRPr lang="en-US" sz="1500" dirty="0"/>
           </a:p>
@@ -4265,7 +4265,7 @@
                 <a:ea typeface="Microsoft YaHei" pitchFamily="34" charset="-122"/>
                 <a:cs typeface="Microsoft YaHei" pitchFamily="34" charset="-120"/>
               </a:rPr>
-              <a:t>未命中高精度规则</a:t>
+              <a:t>高精度 / 行为均未命中</a:t>
             </a:r>
             <a:endParaRPr lang="en-US" sz="1500" dirty="0"/>
           </a:p>
@@ -4357,7 +4357,7 @@
               <a:buNone/>
             </a:pPr>
             <a:r>
-              <a:rPr lang="en-US" sz="1300" b="1" dirty="0">
+              <a:rPr lang="en-US" sz="1250" b="1" dirty="0">
                 <a:solidFill>
                   <a:srgbClr val="37B7AD"/>
                 </a:solidFill>
@@ -4365,13 +4365,13 @@
                 <a:ea typeface="Microsoft YaHei" pitchFamily="34" charset="-122"/>
                 <a:cs typeface="Microsoft YaHei" pitchFamily="34" charset="-120"/>
               </a:rPr>
-              <a:t>供应商级信号（入口 B）同样并入：</a:t>
+              <a:t>为何如此从严：</a:t>
             </a:r>
             <a:pPr indent="0" marL="0">
               <a:buNone/>
             </a:pPr>
             <a:r>
-              <a:rPr lang="en-US" sz="1300" dirty="0">
+              <a:rPr lang="en-US" sz="1250" dirty="0">
                 <a:solidFill>
                   <a:srgbClr val="DDEBEF"/>
                 </a:solidFill>
@@ -4379,9 +4379,9 @@
                 <a:ea typeface="Microsoft YaHei" pitchFamily="34" charset="-122"/>
                 <a:cs typeface="Microsoft YaHei" pitchFamily="34" charset="-120"/>
               </a:rPr>
-              <a:t>拆分 + 旗下高精度命中 → T1；单一行为信号（拆分 / 突增 / 多次命中）→ T2。</a:t>
-            </a:r>
-            <a:endParaRPr lang="en-US" sz="1300" dirty="0"/>
+              <a:t>这四条是准确率 100% 的确定性校验，单条命中即高置信 → 直接 T1。仅命中供应商级行为信号（拆分 / 突增 / 多次命中）→ T2。</a:t>
+            </a:r>
+            <a:endParaRPr lang="en-US" sz="1250" dirty="0"/>
           </a:p>
         </p:txBody>
       </p:sp>

</xml_diff>

<commit_message>
Restructure tiering slide by tier (T1/T2/T3 columns)
S4 reorganized into three per-tier cards: each shows badge + level +
SLA + hit condition + its rules/signals. The "why so strict" note is
folded into the T1 card (red callout) instead of a separate footer.
T2 lists the three vendor-level signals; T3 explains the weighted
fallback. Applied to both EN and CN decks.

Co-Authored-By: Claude Opus 4.8 (1M context) <noreply@anthropic.com>
</commit_message>
<xml_diff>
--- a/ppt/AML-System-Walkthrough-Legal-CN.pptx
+++ b/ppt/AML-System-Walkthrough-Legal-CN.pptx
@@ -3609,7 +3609,7 @@
                 <a:ea typeface="Microsoft YaHei" pitchFamily="34" charset="-122"/>
                 <a:cs typeface="Microsoft YaHei" pitchFamily="34" charset="-120"/>
               </a:rPr>
-              <a:t>分级逻辑：命中任意一条高精度规则即 T1</a:t>
+              <a:t>三个等级：逐级说明</a:t>
             </a:r>
             <a:endParaRPr lang="en-US" sz="3000" dirty="0"/>
           </a:p>
@@ -3624,11 +3624,11 @@
         <p:spPr>
           <a:xfrm>
             <a:off x="548640" y="1828800"/>
-            <a:ext cx="5074920" cy="3520440"/>
+            <a:ext cx="3511296" cy="4160520"/>
           </a:xfrm>
           <a:prstGeom prst="roundRect">
             <a:avLst>
-              <a:gd name="adj" fmla="val 3117"/>
+              <a:gd name="adj" fmla="val 3646"/>
             </a:avLst>
           </a:prstGeom>
           <a:solidFill>
@@ -3657,8 +3657,51 @@
         </p:nvSpPr>
         <p:spPr>
           <a:xfrm>
-            <a:off x="822960" y="2029968"/>
-            <a:ext cx="4572000" cy="365760"/>
+            <a:off x="822960" y="2103120"/>
+            <a:ext cx="868680" cy="566928"/>
+          </a:xfrm>
+          <a:prstGeom prst="rect">
+            <a:avLst>
+              <a:gd name="adj" fmla="val 12903"/>
+            </a:avLst>
+          </a:prstGeom>
+          <a:solidFill>
+            <a:srgbClr val="D84B4B"/>
+          </a:solidFill>
+          <a:ln/>
+        </p:spPr>
+        <p:txBody>
+          <a:bodyPr wrap="square" rtlCol="0" anchor="ctr"/>
+          <a:lstStyle/>
+          <a:p>
+            <a:pPr algn="ctr" indent="0" marL="0">
+              <a:buNone/>
+            </a:pPr>
+            <a:r>
+              <a:rPr lang="en-US" sz="2000" b="1" dirty="0">
+                <a:solidFill>
+                  <a:srgbClr val="FFFFFF"/>
+                </a:solidFill>
+                <a:latin typeface="Microsoft YaHei" pitchFamily="34" charset="0"/>
+                <a:ea typeface="Microsoft YaHei" pitchFamily="34" charset="-122"/>
+                <a:cs typeface="Microsoft YaHei" pitchFamily="34" charset="-120"/>
+              </a:rPr>
+              <a:t>T1</a:t>
+            </a:r>
+            <a:endParaRPr lang="en-US" sz="2000" dirty="0"/>
+          </a:p>
+        </p:txBody>
+      </p:sp>
+      <p:sp>
+        <p:nvSpPr>
+          <p:cNvPr id="6" name="Text 4"/>
+          <p:cNvSpPr/>
+          <p:nvPr/>
+        </p:nvSpPr>
+        <p:spPr>
+          <a:xfrm>
+            <a:off x="1828800" y="2103120"/>
+            <a:ext cx="2011680" cy="365760"/>
           </a:xfrm>
           <a:prstGeom prst="rect">
             <a:avLst/>
@@ -3674,7 +3717,7 @@
               <a:buNone/>
             </a:pPr>
             <a:r>
-              <a:rPr lang="en-US" sz="1600" b="1" dirty="0">
+              <a:rPr lang="en-US" sz="1700" b="1" dirty="0">
                 <a:solidFill>
                   <a:srgbClr val="17313F"/>
                 </a:solidFill>
@@ -3682,22 +3725,22 @@
                 <a:ea typeface="Microsoft YaHei" pitchFamily="34" charset="-122"/>
                 <a:cs typeface="Microsoft YaHei" pitchFamily="34" charset="-120"/>
               </a:rPr>
-              <a:t>付款级硬规则（入口 A）</a:t>
-            </a:r>
-            <a:endParaRPr lang="en-US" sz="1600" dirty="0"/>
-          </a:p>
-        </p:txBody>
-      </p:sp>
-      <p:sp>
-        <p:nvSpPr>
-          <p:cNvPr id="6" name="Text 4"/>
-          <p:cNvSpPr/>
-          <p:nvPr/>
-        </p:nvSpPr>
-        <p:spPr>
-          <a:xfrm>
-            <a:off x="822960" y="2432304"/>
-            <a:ext cx="4572000" cy="320040"/>
+              <a:t>紧急</a:t>
+            </a:r>
+            <a:endParaRPr lang="en-US" sz="1700" dirty="0"/>
+          </a:p>
+        </p:txBody>
+      </p:sp>
+      <p:sp>
+        <p:nvSpPr>
+          <p:cNvPr id="7" name="Text 5"/>
+          <p:cNvSpPr/>
+          <p:nvPr/>
+        </p:nvSpPr>
+        <p:spPr>
+          <a:xfrm>
+            <a:off x="1828800" y="2487168"/>
+            <a:ext cx="2011680" cy="292608"/>
           </a:xfrm>
           <a:prstGeom prst="rect">
             <a:avLst/>
@@ -3713,7 +3756,7 @@
               <a:buNone/>
             </a:pPr>
             <a:r>
-              <a:rPr lang="en-US" sz="1150" dirty="0">
+              <a:rPr lang="en-US" sz="1100" dirty="0">
                 <a:solidFill>
                   <a:srgbClr val="71838F"/>
                 </a:solidFill>
@@ -3721,22 +3764,87 @@
                 <a:ea typeface="Microsoft YaHei" pitchFamily="34" charset="-122"/>
                 <a:cs typeface="Microsoft YaHei" pitchFamily="34" charset="-120"/>
               </a:rPr>
-              <a:t>准确率 100% 的确定性校验 —— 单条命中即高置信</a:t>
-            </a:r>
-            <a:endParaRPr lang="en-US" sz="1150" dirty="0"/>
-          </a:p>
-        </p:txBody>
-      </p:sp>
-      <p:sp>
-        <p:nvSpPr>
-          <p:cNvPr id="7" name="Text 5"/>
-          <p:cNvSpPr/>
-          <p:nvPr/>
-        </p:nvSpPr>
-        <p:spPr>
-          <a:xfrm>
-            <a:off x="914400" y="2926080"/>
-            <a:ext cx="4572000" cy="2194560"/>
+              <a:t>24 小时内复核</a:t>
+            </a:r>
+            <a:endParaRPr lang="en-US" sz="1100" dirty="0"/>
+          </a:p>
+        </p:txBody>
+      </p:sp>
+      <p:sp>
+        <p:nvSpPr>
+          <p:cNvPr id="8" name="Shape 6"/>
+          <p:cNvSpPr/>
+          <p:nvPr/>
+        </p:nvSpPr>
+        <p:spPr>
+          <a:xfrm>
+            <a:off x="822960" y="2880360"/>
+            <a:ext cx="2962656" cy="0"/>
+          </a:xfrm>
+          <a:prstGeom prst="line">
+            <a:avLst/>
+          </a:prstGeom>
+          <a:noFill/>
+          <a:ln w="12700">
+            <a:solidFill>
+              <a:srgbClr val="DCE8EE"/>
+            </a:solidFill>
+            <a:prstDash val="solid"/>
+          </a:ln>
+        </p:spPr>
+      </p:sp>
+      <p:sp>
+        <p:nvSpPr>
+          <p:cNvPr id="9" name="Text 7"/>
+          <p:cNvSpPr/>
+          <p:nvPr/>
+        </p:nvSpPr>
+        <p:spPr>
+          <a:xfrm>
+            <a:off x="822960" y="2980944"/>
+            <a:ext cx="2962656" cy="548640"/>
+          </a:xfrm>
+          <a:prstGeom prst="rect">
+            <a:avLst/>
+          </a:prstGeom>
+          <a:noFill/>
+          <a:ln/>
+        </p:spPr>
+        <p:txBody>
+          <a:bodyPr wrap="square" rtlCol="0" anchor="ctr"/>
+          <a:lstStyle/>
+          <a:p>
+            <a:pPr indent="0" marL="0">
+              <a:lnSpc>
+                <a:spcPct val="105000"/>
+              </a:lnSpc>
+              <a:buNone/>
+            </a:pPr>
+            <a:r>
+              <a:rPr lang="en-US" sz="1400" b="1" dirty="0">
+                <a:solidFill>
+                  <a:srgbClr val="17313F"/>
+                </a:solidFill>
+                <a:latin typeface="Microsoft YaHei" pitchFamily="34" charset="0"/>
+                <a:ea typeface="Microsoft YaHei" pitchFamily="34" charset="-122"/>
+                <a:cs typeface="Microsoft YaHei" pitchFamily="34" charset="-120"/>
+              </a:rPr>
+              <a:t>命中任意 1 条高精度规则</a:t>
+            </a:r>
+            <a:endParaRPr lang="en-US" sz="1400" dirty="0"/>
+          </a:p>
+        </p:txBody>
+      </p:sp>
+      <p:sp>
+        <p:nvSpPr>
+          <p:cNvPr id="10" name="Text 8"/>
+          <p:cNvSpPr/>
+          <p:nvPr/>
+        </p:nvSpPr>
+        <p:spPr>
+          <a:xfrm>
+            <a:off x="932688" y="3611880"/>
+            <a:ext cx="2852928" cy="1371600"/>
           </a:xfrm>
           <a:prstGeom prst="rect">
             <a:avLst/>
@@ -3753,13 +3861,13 @@
                 <a:spcPct val="100000"/>
               </a:lnSpc>
               <a:spcAft>
-                <a:spcPts val="1200"/>
+                <a:spcPts val="600"/>
               </a:spcAft>
               <a:buSzPct val="100000"/>
               <a:buChar char="•"/>
             </a:pPr>
             <a:r>
-              <a:rPr lang="en-US" sz="1400" dirty="0">
+              <a:rPr lang="en-US" sz="1200" dirty="0">
                 <a:solidFill>
                   <a:srgbClr val="17313F"/>
                 </a:solidFill>
@@ -3769,7 +3877,7 @@
               </a:rPr>
               <a:t>银行 / 营业地国家不一致</a:t>
             </a:r>
-            <a:endParaRPr lang="en-US" sz="1400" dirty="0"/>
+            <a:endParaRPr lang="en-US" sz="1200" dirty="0"/>
           </a:p>
           <a:p>
             <a:pPr marL="342900" indent="-342900">
@@ -3777,13 +3885,13 @@
                 <a:spcPct val="100000"/>
               </a:lnSpc>
               <a:spcAft>
-                <a:spcPts val="1200"/>
+                <a:spcPts val="600"/>
               </a:spcAft>
               <a:buSzPct val="100000"/>
               <a:buChar char="•"/>
             </a:pPr>
             <a:r>
-              <a:rPr lang="en-US" sz="1400" dirty="0">
+              <a:rPr lang="en-US" sz="1200" dirty="0">
                 <a:solidFill>
                   <a:srgbClr val="17313F"/>
                 </a:solidFill>
@@ -3793,7 +3901,7 @@
               </a:rPr>
               <a:t>付款方 / 发票来源国不一致</a:t>
             </a:r>
-            <a:endParaRPr lang="en-US" sz="1400" dirty="0"/>
+            <a:endParaRPr lang="en-US" sz="1200" dirty="0"/>
           </a:p>
           <a:p>
             <a:pPr marL="342900" indent="-342900">
@@ -3801,13 +3909,13 @@
                 <a:spcPct val="100000"/>
               </a:lnSpc>
               <a:spcAft>
-                <a:spcPts val="1200"/>
+                <a:spcPts val="600"/>
               </a:spcAft>
               <a:buSzPct val="100000"/>
               <a:buChar char="•"/>
             </a:pPr>
             <a:r>
-              <a:rPr lang="en-US" sz="1400" dirty="0">
+              <a:rPr lang="en-US" sz="1200" dirty="0">
                 <a:solidFill>
                   <a:srgbClr val="17313F"/>
                 </a:solidFill>
@@ -3817,7 +3925,7 @@
               </a:rPr>
               <a:t>主营业务 ≠ 采购品类</a:t>
             </a:r>
-            <a:endParaRPr lang="en-US" sz="1400" dirty="0"/>
+            <a:endParaRPr lang="en-US" sz="1200" dirty="0"/>
           </a:p>
           <a:p>
             <a:pPr marL="342900" indent="-342900">
@@ -3825,13 +3933,13 @@
                 <a:spcPct val="100000"/>
               </a:lnSpc>
               <a:spcAft>
-                <a:spcPts val="1200"/>
+                <a:spcPts val="600"/>
               </a:spcAft>
               <a:buSzPct val="100000"/>
               <a:buChar char="•"/>
             </a:pPr>
             <a:r>
-              <a:rPr lang="en-US" sz="1400" dirty="0">
+              <a:rPr lang="en-US" sz="1200" dirty="0">
                 <a:solidFill>
                   <a:srgbClr val="17313F"/>
                 </a:solidFill>
@@ -3841,24 +3949,110 @@
               </a:rPr>
               <a:t>虚假发票特征</a:t>
             </a:r>
-            <a:endParaRPr lang="en-US" sz="1400" dirty="0"/>
-          </a:p>
-        </p:txBody>
-      </p:sp>
-      <p:sp>
-        <p:nvSpPr>
-          <p:cNvPr id="8" name="Shape 6"/>
-          <p:cNvSpPr/>
-          <p:nvPr/>
-        </p:nvSpPr>
-        <p:spPr>
-          <a:xfrm>
-            <a:off x="5989320" y="1828800"/>
-            <a:ext cx="5650992" cy="1005840"/>
+            <a:endParaRPr lang="en-US" sz="1200" dirty="0"/>
+          </a:p>
+        </p:txBody>
+      </p:sp>
+      <p:sp>
+        <p:nvSpPr>
+          <p:cNvPr id="11" name="Shape 9"/>
+          <p:cNvSpPr/>
+          <p:nvPr/>
+        </p:nvSpPr>
+        <p:spPr>
+          <a:xfrm>
+            <a:off x="822960" y="4983480"/>
+            <a:ext cx="2962656" cy="868680"/>
           </a:xfrm>
           <a:prstGeom prst="roundRect">
             <a:avLst>
-              <a:gd name="adj" fmla="val 10909"/>
+              <a:gd name="adj" fmla="val 10526"/>
+            </a:avLst>
+          </a:prstGeom>
+          <a:solidFill>
+            <a:srgbClr val="FBEEEE"/>
+          </a:solidFill>
+          <a:ln w="12700">
+            <a:solidFill>
+              <a:srgbClr val="F0C9C9"/>
+            </a:solidFill>
+            <a:prstDash val="solid"/>
+          </a:ln>
+        </p:spPr>
+      </p:sp>
+      <p:sp>
+        <p:nvSpPr>
+          <p:cNvPr id="12" name="Text 10"/>
+          <p:cNvSpPr/>
+          <p:nvPr/>
+        </p:nvSpPr>
+        <p:spPr>
+          <a:xfrm>
+            <a:off x="960120" y="5029200"/>
+            <a:ext cx="2688336" cy="777240"/>
+          </a:xfrm>
+          <a:prstGeom prst="rect">
+            <a:avLst/>
+          </a:prstGeom>
+          <a:noFill/>
+          <a:ln/>
+        </p:spPr>
+        <p:txBody>
+          <a:bodyPr wrap="square" rtlCol="0" anchor="ctr"/>
+          <a:lstStyle/>
+          <a:p>
+            <a:pPr indent="0" marL="0">
+              <a:lnSpc>
+                <a:spcPct val="110000"/>
+              </a:lnSpc>
+              <a:buNone/>
+            </a:pPr>
+            <a:r>
+              <a:rPr lang="en-US" sz="1100" b="1" dirty="0">
+                <a:solidFill>
+                  <a:srgbClr val="D84B4B"/>
+                </a:solidFill>
+                <a:latin typeface="Microsoft YaHei" pitchFamily="34" charset="0"/>
+                <a:ea typeface="Microsoft YaHei" pitchFamily="34" charset="-122"/>
+                <a:cs typeface="Microsoft YaHei" pitchFamily="34" charset="-120"/>
+              </a:rPr>
+              <a:t>为何直接 T1：</a:t>
+            </a:r>
+            <a:pPr indent="0" marL="0">
+              <a:lnSpc>
+                <a:spcPct val="110000"/>
+              </a:lnSpc>
+              <a:buNone/>
+            </a:pPr>
+            <a:r>
+              <a:rPr lang="en-US" sz="1100" dirty="0">
+                <a:solidFill>
+                  <a:srgbClr val="17313F"/>
+                </a:solidFill>
+                <a:latin typeface="Microsoft YaHei" pitchFamily="34" charset="0"/>
+                <a:ea typeface="Microsoft YaHei" pitchFamily="34" charset="-122"/>
+                <a:cs typeface="Microsoft YaHei" pitchFamily="34" charset="-120"/>
+              </a:rPr>
+              <a:t>准确率 100% 的确定性校验，单条命中即高置信。</a:t>
+            </a:r>
+            <a:endParaRPr lang="en-US" sz="1100" dirty="0"/>
+          </a:p>
+        </p:txBody>
+      </p:sp>
+      <p:sp>
+        <p:nvSpPr>
+          <p:cNvPr id="13" name="Shape 11"/>
+          <p:cNvSpPr/>
+          <p:nvPr/>
+        </p:nvSpPr>
+        <p:spPr>
+          <a:xfrm>
+            <a:off x="4338828" y="1828800"/>
+            <a:ext cx="3511296" cy="4160520"/>
+          </a:xfrm>
+          <a:prstGeom prst="roundRect">
+            <a:avLst>
+              <a:gd name="adj" fmla="val 3646"/>
             </a:avLst>
           </a:prstGeom>
           <a:solidFill>
@@ -3881,22 +4075,22 @@
       </p:sp>
       <p:sp>
         <p:nvSpPr>
-          <p:cNvPr id="9" name="Text 7"/>
-          <p:cNvSpPr/>
-          <p:nvPr/>
-        </p:nvSpPr>
-        <p:spPr>
-          <a:xfrm>
-            <a:off x="6217920" y="2057400"/>
-            <a:ext cx="914400" cy="548640"/>
+          <p:cNvPr id="14" name="Text 12"/>
+          <p:cNvSpPr/>
+          <p:nvPr/>
+        </p:nvSpPr>
+        <p:spPr>
+          <a:xfrm>
+            <a:off x="4613148" y="2103120"/>
+            <a:ext cx="868680" cy="566928"/>
           </a:xfrm>
           <a:prstGeom prst="rect">
             <a:avLst>
-              <a:gd name="adj" fmla="val 13333"/>
+              <a:gd name="adj" fmla="val 12903"/>
             </a:avLst>
           </a:prstGeom>
           <a:solidFill>
-            <a:srgbClr val="D84B4B"/>
+            <a:srgbClr val="C9861A"/>
           </a:solidFill>
           <a:ln/>
         </p:spPr>
@@ -3916,7 +4110,7 @@
                 <a:ea typeface="Microsoft YaHei" pitchFamily="34" charset="-122"/>
                 <a:cs typeface="Microsoft YaHei" pitchFamily="34" charset="-120"/>
               </a:rPr>
-              <a:t>T1</a:t>
+              <a:t>T2</a:t>
             </a:r>
             <a:endParaRPr lang="en-US" sz="2000" dirty="0"/>
           </a:p>
@@ -3924,14 +4118,14 @@
       </p:sp>
       <p:sp>
         <p:nvSpPr>
-          <p:cNvPr id="10" name="Text 8"/>
-          <p:cNvSpPr/>
-          <p:nvPr/>
-        </p:nvSpPr>
-        <p:spPr>
-          <a:xfrm>
-            <a:off x="7360920" y="1975104"/>
-            <a:ext cx="4114800" cy="384048"/>
+          <p:cNvPr id="15" name="Text 13"/>
+          <p:cNvSpPr/>
+          <p:nvPr/>
+        </p:nvSpPr>
+        <p:spPr>
+          <a:xfrm>
+            <a:off x="5618988" y="2103120"/>
+            <a:ext cx="2011680" cy="365760"/>
           </a:xfrm>
           <a:prstGeom prst="rect">
             <a:avLst/>
@@ -3947,7 +4141,7 @@
               <a:buNone/>
             </a:pPr>
             <a:r>
-              <a:rPr lang="en-US" sz="1500" b="1" dirty="0">
+              <a:rPr lang="en-US" sz="1700" b="1" dirty="0">
                 <a:solidFill>
                   <a:srgbClr val="17313F"/>
                 </a:solidFill>
@@ -3955,22 +4149,22 @@
                 <a:ea typeface="Microsoft YaHei" pitchFamily="34" charset="-122"/>
                 <a:cs typeface="Microsoft YaHei" pitchFamily="34" charset="-120"/>
               </a:rPr>
-              <a:t>命中任意 1 条高精度规则</a:t>
-            </a:r>
-            <a:endParaRPr lang="en-US" sz="1500" dirty="0"/>
-          </a:p>
-        </p:txBody>
-      </p:sp>
-      <p:sp>
-        <p:nvSpPr>
-          <p:cNvPr id="11" name="Text 9"/>
-          <p:cNvSpPr/>
-          <p:nvPr/>
-        </p:nvSpPr>
-        <p:spPr>
-          <a:xfrm>
-            <a:off x="7360920" y="2359152"/>
-            <a:ext cx="4114800" cy="347472"/>
+              <a:t>告警</a:t>
+            </a:r>
+            <a:endParaRPr lang="en-US" sz="1700" dirty="0"/>
+          </a:p>
+        </p:txBody>
+      </p:sp>
+      <p:sp>
+        <p:nvSpPr>
+          <p:cNvPr id="16" name="Text 14"/>
+          <p:cNvSpPr/>
+          <p:nvPr/>
+        </p:nvSpPr>
+        <p:spPr>
+          <a:xfrm>
+            <a:off x="5618988" y="2487168"/>
+            <a:ext cx="2011680" cy="292608"/>
           </a:xfrm>
           <a:prstGeom prst="rect">
             <a:avLst/>
@@ -3986,7 +4180,7 @@
               <a:buNone/>
             </a:pPr>
             <a:r>
-              <a:rPr lang="en-US" sz="1200" dirty="0">
+              <a:rPr lang="en-US" sz="1100" dirty="0">
                 <a:solidFill>
                   <a:srgbClr val="71838F"/>
                 </a:solidFill>
@@ -3994,26 +4188,224 @@
                 <a:ea typeface="Microsoft YaHei" pitchFamily="34" charset="-122"/>
                 <a:cs typeface="Microsoft YaHei" pitchFamily="34" charset="-120"/>
               </a:rPr>
-              <a:t>紧急 · 24 小时内复核</a:t>
-            </a:r>
-            <a:endParaRPr lang="en-US" sz="1200" dirty="0"/>
-          </a:p>
-        </p:txBody>
-      </p:sp>
-      <p:sp>
-        <p:nvSpPr>
-          <p:cNvPr id="12" name="Shape 10"/>
-          <p:cNvSpPr/>
-          <p:nvPr/>
-        </p:nvSpPr>
-        <p:spPr>
-          <a:xfrm>
-            <a:off x="5989320" y="3017520"/>
-            <a:ext cx="5650992" cy="1005840"/>
+              <a:t>3 天内复核</a:t>
+            </a:r>
+            <a:endParaRPr lang="en-US" sz="1100" dirty="0"/>
+          </a:p>
+        </p:txBody>
+      </p:sp>
+      <p:sp>
+        <p:nvSpPr>
+          <p:cNvPr id="17" name="Shape 15"/>
+          <p:cNvSpPr/>
+          <p:nvPr/>
+        </p:nvSpPr>
+        <p:spPr>
+          <a:xfrm>
+            <a:off x="4613148" y="2880360"/>
+            <a:ext cx="2962656" cy="0"/>
+          </a:xfrm>
+          <a:prstGeom prst="line">
+            <a:avLst/>
+          </a:prstGeom>
+          <a:noFill/>
+          <a:ln w="12700">
+            <a:solidFill>
+              <a:srgbClr val="DCE8EE"/>
+            </a:solidFill>
+            <a:prstDash val="solid"/>
+          </a:ln>
+        </p:spPr>
+      </p:sp>
+      <p:sp>
+        <p:nvSpPr>
+          <p:cNvPr id="18" name="Text 16"/>
+          <p:cNvSpPr/>
+          <p:nvPr/>
+        </p:nvSpPr>
+        <p:spPr>
+          <a:xfrm>
+            <a:off x="4613148" y="2980944"/>
+            <a:ext cx="2962656" cy="548640"/>
+          </a:xfrm>
+          <a:prstGeom prst="rect">
+            <a:avLst/>
+          </a:prstGeom>
+          <a:noFill/>
+          <a:ln/>
+        </p:spPr>
+        <p:txBody>
+          <a:bodyPr wrap="square" rtlCol="0" anchor="ctr"/>
+          <a:lstStyle/>
+          <a:p>
+            <a:pPr indent="0" marL="0">
+              <a:lnSpc>
+                <a:spcPct val="105000"/>
+              </a:lnSpc>
+              <a:buNone/>
+            </a:pPr>
+            <a:r>
+              <a:rPr lang="en-US" sz="1400" b="1" dirty="0">
+                <a:solidFill>
+                  <a:srgbClr val="17313F"/>
+                </a:solidFill>
+                <a:latin typeface="Microsoft YaHei" pitchFamily="34" charset="0"/>
+                <a:ea typeface="Microsoft YaHei" pitchFamily="34" charset="-122"/>
+                <a:cs typeface="Microsoft YaHei" pitchFamily="34" charset="-120"/>
+              </a:rPr>
+              <a:t>仅命中供应商级信号（无硬规则命中）</a:t>
+            </a:r>
+            <a:endParaRPr lang="en-US" sz="1400" dirty="0"/>
+          </a:p>
+        </p:txBody>
+      </p:sp>
+      <p:sp>
+        <p:nvSpPr>
+          <p:cNvPr id="19" name="Text 17"/>
+          <p:cNvSpPr/>
+          <p:nvPr/>
+        </p:nvSpPr>
+        <p:spPr>
+          <a:xfrm>
+            <a:off x="4613148" y="3611880"/>
+            <a:ext cx="2962656" cy="320040"/>
+          </a:xfrm>
+          <a:prstGeom prst="rect">
+            <a:avLst/>
+          </a:prstGeom>
+          <a:noFill/>
+          <a:ln/>
+        </p:spPr>
+        <p:txBody>
+          <a:bodyPr wrap="square" rtlCol="0" anchor="ctr"/>
+          <a:lstStyle/>
+          <a:p>
+            <a:pPr indent="0" marL="0">
+              <a:buNone/>
+            </a:pPr>
+            <a:r>
+              <a:rPr lang="en-US" sz="1100" dirty="0">
+                <a:solidFill>
+                  <a:srgbClr val="71838F"/>
+                </a:solidFill>
+                <a:latin typeface="Microsoft YaHei" pitchFamily="34" charset="0"/>
+                <a:ea typeface="Microsoft YaHei" pitchFamily="34" charset="-122"/>
+                <a:cs typeface="Microsoft YaHei" pitchFamily="34" charset="-120"/>
+              </a:rPr>
+              <a:t>命中以下任一供应商级行为信号：</a:t>
+            </a:r>
+            <a:endParaRPr lang="en-US" sz="1100" dirty="0"/>
+          </a:p>
+        </p:txBody>
+      </p:sp>
+      <p:sp>
+        <p:nvSpPr>
+          <p:cNvPr id="20" name="Text 18"/>
+          <p:cNvSpPr/>
+          <p:nvPr/>
+        </p:nvSpPr>
+        <p:spPr>
+          <a:xfrm>
+            <a:off x="4722876" y="4023360"/>
+            <a:ext cx="2852928" cy="1463040"/>
+          </a:xfrm>
+          <a:prstGeom prst="rect">
+            <a:avLst/>
+          </a:prstGeom>
+          <a:noFill/>
+          <a:ln/>
+        </p:spPr>
+        <p:txBody>
+          <a:bodyPr wrap="square" rtlCol="0" anchor="ctr"/>
+          <a:lstStyle/>
+          <a:p>
+            <a:pPr marL="342900" indent="-342900">
+              <a:lnSpc>
+                <a:spcPct val="100000"/>
+              </a:lnSpc>
+              <a:spcAft>
+                <a:spcPts val="800"/>
+              </a:spcAft>
+              <a:buSzPct val="100000"/>
+              <a:buChar char="•"/>
+            </a:pPr>
+            <a:r>
+              <a:rPr lang="en-US" sz="1250" dirty="0">
+                <a:solidFill>
+                  <a:srgbClr val="17313F"/>
+                </a:solidFill>
+                <a:latin typeface="Microsoft YaHei" pitchFamily="34" charset="0"/>
+                <a:ea typeface="Microsoft YaHei" pitchFamily="34" charset="-122"/>
+                <a:cs typeface="Microsoft YaHei" pitchFamily="34" charset="-120"/>
+              </a:rPr>
+              <a:t>拆分付款（化整为零）</a:t>
+            </a:r>
+            <a:endParaRPr lang="en-US" sz="1250" dirty="0"/>
+          </a:p>
+          <a:p>
+            <a:pPr marL="342900" indent="-342900">
+              <a:lnSpc>
+                <a:spcPct val="100000"/>
+              </a:lnSpc>
+              <a:spcAft>
+                <a:spcPts val="800"/>
+              </a:spcAft>
+              <a:buSzPct val="100000"/>
+              <a:buChar char="•"/>
+            </a:pPr>
+            <a:r>
+              <a:rPr lang="en-US" sz="1250" dirty="0">
+                <a:solidFill>
+                  <a:srgbClr val="17313F"/>
+                </a:solidFill>
+                <a:latin typeface="Microsoft YaHei" pitchFamily="34" charset="0"/>
+                <a:ea typeface="Microsoft YaHei" pitchFamily="34" charset="-122"/>
+                <a:cs typeface="Microsoft YaHei" pitchFamily="34" charset="-120"/>
+              </a:rPr>
+              <a:t>付款突增（新供应商）</a:t>
+            </a:r>
+            <a:endParaRPr lang="en-US" sz="1250" dirty="0"/>
+          </a:p>
+          <a:p>
+            <a:pPr marL="342900" indent="-342900">
+              <a:lnSpc>
+                <a:spcPct val="100000"/>
+              </a:lnSpc>
+              <a:spcAft>
+                <a:spcPts val="800"/>
+              </a:spcAft>
+              <a:buSzPct val="100000"/>
+              <a:buChar char="•"/>
+            </a:pPr>
+            <a:r>
+              <a:rPr lang="en-US" sz="1250" dirty="0">
+                <a:solidFill>
+                  <a:srgbClr val="17313F"/>
+                </a:solidFill>
+                <a:latin typeface="Microsoft YaHei" pitchFamily="34" charset="0"/>
+                <a:ea typeface="Microsoft YaHei" pitchFamily="34" charset="-122"/>
+                <a:cs typeface="Microsoft YaHei" pitchFamily="34" charset="-120"/>
+              </a:rPr>
+              <a:t>高精度规则多次命中</a:t>
+            </a:r>
+            <a:endParaRPr lang="en-US" sz="1250" dirty="0"/>
+          </a:p>
+        </p:txBody>
+      </p:sp>
+      <p:sp>
+        <p:nvSpPr>
+          <p:cNvPr id="21" name="Shape 19"/>
+          <p:cNvSpPr/>
+          <p:nvPr/>
+        </p:nvSpPr>
+        <p:spPr>
+          <a:xfrm>
+            <a:off x="8129016" y="1828800"/>
+            <a:ext cx="3511296" cy="4160520"/>
           </a:xfrm>
           <a:prstGeom prst="roundRect">
             <a:avLst>
-              <a:gd name="adj" fmla="val 10909"/>
+              <a:gd name="adj" fmla="val 3646"/>
             </a:avLst>
           </a:prstGeom>
           <a:solidFill>
@@ -4036,22 +4428,22 @@
       </p:sp>
       <p:sp>
         <p:nvSpPr>
-          <p:cNvPr id="13" name="Text 11"/>
-          <p:cNvSpPr/>
-          <p:nvPr/>
-        </p:nvSpPr>
-        <p:spPr>
-          <a:xfrm>
-            <a:off x="6217920" y="3246120"/>
-            <a:ext cx="914400" cy="548640"/>
+          <p:cNvPr id="22" name="Text 20"/>
+          <p:cNvSpPr/>
+          <p:nvPr/>
+        </p:nvSpPr>
+        <p:spPr>
+          <a:xfrm>
+            <a:off x="8403336" y="2103120"/>
+            <a:ext cx="868680" cy="566928"/>
           </a:xfrm>
           <a:prstGeom prst="rect">
             <a:avLst>
-              <a:gd name="adj" fmla="val 13333"/>
+              <a:gd name="adj" fmla="val 12903"/>
             </a:avLst>
           </a:prstGeom>
           <a:solidFill>
-            <a:srgbClr val="C9861A"/>
+            <a:srgbClr val="5D8AA8"/>
           </a:solidFill>
           <a:ln/>
         </p:spPr>
@@ -4071,7 +4463,7 @@
                 <a:ea typeface="Microsoft YaHei" pitchFamily="34" charset="-122"/>
                 <a:cs typeface="Microsoft YaHei" pitchFamily="34" charset="-120"/>
               </a:rPr>
-              <a:t>T2</a:t>
+              <a:t>T3</a:t>
             </a:r>
             <a:endParaRPr lang="en-US" sz="2000" dirty="0"/>
           </a:p>
@@ -4079,14 +4471,14 @@
       </p:sp>
       <p:sp>
         <p:nvSpPr>
-          <p:cNvPr id="14" name="Text 12"/>
-          <p:cNvSpPr/>
-          <p:nvPr/>
-        </p:nvSpPr>
-        <p:spPr>
-          <a:xfrm>
-            <a:off x="7360920" y="3163824"/>
-            <a:ext cx="4114800" cy="384048"/>
+          <p:cNvPr id="23" name="Text 21"/>
+          <p:cNvSpPr/>
+          <p:nvPr/>
+        </p:nvSpPr>
+        <p:spPr>
+          <a:xfrm>
+            <a:off x="9409176" y="2103120"/>
+            <a:ext cx="2011680" cy="365760"/>
           </a:xfrm>
           <a:prstGeom prst="rect">
             <a:avLst/>
@@ -4102,7 +4494,7 @@
               <a:buNone/>
             </a:pPr>
             <a:r>
-              <a:rPr lang="en-US" sz="1500" b="1" dirty="0">
+              <a:rPr lang="en-US" sz="1700" b="1" dirty="0">
                 <a:solidFill>
                   <a:srgbClr val="17313F"/>
                 </a:solidFill>
@@ -4110,22 +4502,22 @@
                 <a:ea typeface="Microsoft YaHei" pitchFamily="34" charset="-122"/>
                 <a:cs typeface="Microsoft YaHei" pitchFamily="34" charset="-120"/>
               </a:rPr>
-              <a:t>仅命中供应商级信号</a:t>
-            </a:r>
-            <a:endParaRPr lang="en-US" sz="1500" dirty="0"/>
-          </a:p>
-        </p:txBody>
-      </p:sp>
-      <p:sp>
-        <p:nvSpPr>
-          <p:cNvPr id="15" name="Text 13"/>
-          <p:cNvSpPr/>
-          <p:nvPr/>
-        </p:nvSpPr>
-        <p:spPr>
-          <a:xfrm>
-            <a:off x="7360920" y="3547872"/>
-            <a:ext cx="4114800" cy="347472"/>
+              <a:t>评分</a:t>
+            </a:r>
+            <a:endParaRPr lang="en-US" sz="1700" dirty="0"/>
+          </a:p>
+        </p:txBody>
+      </p:sp>
+      <p:sp>
+        <p:nvSpPr>
+          <p:cNvPr id="24" name="Text 22"/>
+          <p:cNvSpPr/>
+          <p:nvPr/>
+        </p:nvSpPr>
+        <p:spPr>
+          <a:xfrm>
+            <a:off x="9409176" y="2487168"/>
+            <a:ext cx="2011680" cy="292608"/>
           </a:xfrm>
           <a:prstGeom prst="rect">
             <a:avLst/>
@@ -4141,7 +4533,7 @@
               <a:buNone/>
             </a:pPr>
             <a:r>
-              <a:rPr lang="en-US" sz="1200" dirty="0">
+              <a:rPr lang="en-US" sz="1100" dirty="0">
                 <a:solidFill>
                   <a:srgbClr val="71838F"/>
                 </a:solidFill>
@@ -4149,99 +4541,45 @@
                 <a:ea typeface="Microsoft YaHei" pitchFamily="34" charset="-122"/>
                 <a:cs typeface="Microsoft YaHei" pitchFamily="34" charset="-120"/>
               </a:rPr>
-              <a:t>告警 · 3 天内复核</a:t>
-            </a:r>
-            <a:endParaRPr lang="en-US" sz="1200" dirty="0"/>
-          </a:p>
-        </p:txBody>
-      </p:sp>
-      <p:sp>
-        <p:nvSpPr>
-          <p:cNvPr id="16" name="Shape 14"/>
-          <p:cNvSpPr/>
-          <p:nvPr/>
-        </p:nvSpPr>
-        <p:spPr>
-          <a:xfrm>
-            <a:off x="5989320" y="4206240"/>
-            <a:ext cx="5650992" cy="1005840"/>
-          </a:xfrm>
-          <a:prstGeom prst="roundRect">
-            <a:avLst>
-              <a:gd name="adj" fmla="val 10909"/>
-            </a:avLst>
-          </a:prstGeom>
-          <a:solidFill>
-            <a:srgbClr val="F4FAFB"/>
-          </a:solidFill>
+              <a:t>批量排序</a:t>
+            </a:r>
+            <a:endParaRPr lang="en-US" sz="1100" dirty="0"/>
+          </a:p>
+        </p:txBody>
+      </p:sp>
+      <p:sp>
+        <p:nvSpPr>
+          <p:cNvPr id="25" name="Shape 23"/>
+          <p:cNvSpPr/>
+          <p:nvPr/>
+        </p:nvSpPr>
+        <p:spPr>
+          <a:xfrm>
+            <a:off x="8403336" y="2880360"/>
+            <a:ext cx="2962656" cy="0"/>
+          </a:xfrm>
+          <a:prstGeom prst="line">
+            <a:avLst/>
+          </a:prstGeom>
+          <a:noFill/>
           <a:ln w="12700">
             <a:solidFill>
               <a:srgbClr val="DCE8EE"/>
             </a:solidFill>
             <a:prstDash val="solid"/>
           </a:ln>
-          <a:effectLst>
-            <a:outerShdw sx="100000" sy="100000" kx="0" ky="0" algn="bl" rotWithShape="0" blurRad="114300" dist="38100" dir="8100000">
-              <a:srgbClr val="0B1F2A">
-                <a:alpha val="16000"/>
-              </a:srgbClr>
-            </a:outerShdw>
-          </a:effectLst>
-        </p:spPr>
-      </p:sp>
-      <p:sp>
-        <p:nvSpPr>
-          <p:cNvPr id="17" name="Text 15"/>
-          <p:cNvSpPr/>
-          <p:nvPr/>
-        </p:nvSpPr>
-        <p:spPr>
-          <a:xfrm>
-            <a:off x="6217920" y="4434840"/>
-            <a:ext cx="914400" cy="548640"/>
-          </a:xfrm>
-          <a:prstGeom prst="rect">
-            <a:avLst>
-              <a:gd name="adj" fmla="val 13333"/>
-            </a:avLst>
-          </a:prstGeom>
-          <a:solidFill>
-            <a:srgbClr val="5D8AA8"/>
-          </a:solidFill>
-          <a:ln/>
-        </p:spPr>
-        <p:txBody>
-          <a:bodyPr wrap="square" rtlCol="0" anchor="ctr"/>
-          <a:lstStyle/>
-          <a:p>
-            <a:pPr algn="ctr" indent="0" marL="0">
-              <a:buNone/>
-            </a:pPr>
-            <a:r>
-              <a:rPr lang="en-US" sz="2000" b="1" dirty="0">
-                <a:solidFill>
-                  <a:srgbClr val="FFFFFF"/>
-                </a:solidFill>
-                <a:latin typeface="Microsoft YaHei" pitchFamily="34" charset="0"/>
-                <a:ea typeface="Microsoft YaHei" pitchFamily="34" charset="-122"/>
-                <a:cs typeface="Microsoft YaHei" pitchFamily="34" charset="-120"/>
-              </a:rPr>
-              <a:t>T3</a:t>
-            </a:r>
-            <a:endParaRPr lang="en-US" sz="2000" dirty="0"/>
-          </a:p>
-        </p:txBody>
-      </p:sp>
-      <p:sp>
-        <p:nvSpPr>
-          <p:cNvPr id="18" name="Text 16"/>
-          <p:cNvSpPr/>
-          <p:nvPr/>
-        </p:nvSpPr>
-        <p:spPr>
-          <a:xfrm>
-            <a:off x="7360920" y="4352544"/>
-            <a:ext cx="4114800" cy="384048"/>
+        </p:spPr>
+      </p:sp>
+      <p:sp>
+        <p:nvSpPr>
+          <p:cNvPr id="26" name="Text 24"/>
+          <p:cNvSpPr/>
+          <p:nvPr/>
+        </p:nvSpPr>
+        <p:spPr>
+          <a:xfrm>
+            <a:off x="8403336" y="2980944"/>
+            <a:ext cx="2962656" cy="548640"/>
           </a:xfrm>
           <a:prstGeom prst="rect">
             <a:avLst/>
@@ -4254,10 +4592,13 @@
           <a:lstStyle/>
           <a:p>
             <a:pPr indent="0" marL="0">
-              <a:buNone/>
-            </a:pPr>
-            <a:r>
-              <a:rPr lang="en-US" sz="1500" b="1" dirty="0">
+              <a:lnSpc>
+                <a:spcPct val="105000"/>
+              </a:lnSpc>
+              <a:buNone/>
+            </a:pPr>
+            <a:r>
+              <a:rPr lang="en-US" sz="1400" b="1" dirty="0">
                 <a:solidFill>
                   <a:srgbClr val="17313F"/>
                 </a:solidFill>
@@ -4267,20 +4608,20 @@
               </a:rPr>
               <a:t>高精度 / 行为均未命中</a:t>
             </a:r>
-            <a:endParaRPr lang="en-US" sz="1500" dirty="0"/>
-          </a:p>
-        </p:txBody>
-      </p:sp>
-      <p:sp>
-        <p:nvSpPr>
-          <p:cNvPr id="19" name="Text 17"/>
-          <p:cNvSpPr/>
-          <p:nvPr/>
-        </p:nvSpPr>
-        <p:spPr>
-          <a:xfrm>
-            <a:off x="7360920" y="4736592"/>
-            <a:ext cx="4114800" cy="347472"/>
+            <a:endParaRPr lang="en-US" sz="1400" dirty="0"/>
+          </a:p>
+        </p:txBody>
+      </p:sp>
+      <p:sp>
+        <p:nvSpPr>
+          <p:cNvPr id="27" name="Text 25"/>
+          <p:cNvSpPr/>
+          <p:nvPr/>
+        </p:nvSpPr>
+        <p:spPr>
+          <a:xfrm>
+            <a:off x="8403336" y="3611880"/>
+            <a:ext cx="2962656" cy="1828800"/>
           </a:xfrm>
           <a:prstGeom prst="rect">
             <a:avLst/>
@@ -4293,93 +4634,21 @@
           <a:lstStyle/>
           <a:p>
             <a:pPr indent="0" marL="0">
-              <a:buNone/>
-            </a:pPr>
-            <a:r>
-              <a:rPr lang="en-US" sz="1200" dirty="0">
-                <a:solidFill>
-                  <a:srgbClr val="71838F"/>
-                </a:solidFill>
-                <a:latin typeface="Microsoft YaHei" pitchFamily="34" charset="0"/>
-                <a:ea typeface="Microsoft YaHei" pitchFamily="34" charset="-122"/>
-                <a:cs typeface="Microsoft YaHei" pitchFamily="34" charset="-120"/>
-              </a:rPr>
-              <a:t>评分 · 批量排序（复用原有逻辑）</a:t>
-            </a:r>
-            <a:endParaRPr lang="en-US" sz="1200" dirty="0"/>
-          </a:p>
-        </p:txBody>
-      </p:sp>
-      <p:sp>
-        <p:nvSpPr>
-          <p:cNvPr id="20" name="Shape 18"/>
-          <p:cNvSpPr/>
-          <p:nvPr/>
-        </p:nvSpPr>
-        <p:spPr>
-          <a:xfrm>
-            <a:off x="548640" y="5532120"/>
-            <a:ext cx="11091672" cy="640080"/>
-          </a:xfrm>
-          <a:prstGeom prst="roundRect">
-            <a:avLst>
-              <a:gd name="adj" fmla="val 17143"/>
-            </a:avLst>
-          </a:prstGeom>
-          <a:solidFill>
-            <a:srgbClr val="102C3A"/>
-          </a:solidFill>
-          <a:ln/>
-        </p:spPr>
-      </p:sp>
-      <p:sp>
-        <p:nvSpPr>
-          <p:cNvPr id="21" name="Text 19"/>
-          <p:cNvSpPr/>
-          <p:nvPr/>
-        </p:nvSpPr>
-        <p:spPr>
-          <a:xfrm>
-            <a:off x="822960" y="5532120"/>
-            <a:ext cx="10607040" cy="640080"/>
-          </a:xfrm>
-          <a:prstGeom prst="rect">
-            <a:avLst/>
-          </a:prstGeom>
-          <a:noFill/>
-          <a:ln/>
-        </p:spPr>
-        <p:txBody>
-          <a:bodyPr wrap="square" rtlCol="0" anchor="ctr"/>
-          <a:lstStyle/>
-          <a:p>
-            <a:pPr indent="0" marL="0">
-              <a:buNone/>
-            </a:pPr>
-            <a:r>
-              <a:rPr lang="en-US" sz="1250" b="1" dirty="0">
-                <a:solidFill>
-                  <a:srgbClr val="37B7AD"/>
-                </a:solidFill>
-                <a:latin typeface="Microsoft YaHei" pitchFamily="34" charset="0"/>
-                <a:ea typeface="Microsoft YaHei" pitchFamily="34" charset="-122"/>
-                <a:cs typeface="Microsoft YaHei" pitchFamily="34" charset="-120"/>
-              </a:rPr>
-              <a:t>为何如此从严：</a:t>
-            </a:r>
-            <a:pPr indent="0" marL="0">
+              <a:lnSpc>
+                <a:spcPct val="130000"/>
+              </a:lnSpc>
               <a:buNone/>
             </a:pPr>
             <a:r>
               <a:rPr lang="en-US" sz="1250" dirty="0">
                 <a:solidFill>
-                  <a:srgbClr val="DDEBEF"/>
-                </a:solidFill>
-                <a:latin typeface="Microsoft YaHei" pitchFamily="34" charset="0"/>
-                <a:ea typeface="Microsoft YaHei" pitchFamily="34" charset="-122"/>
-                <a:cs typeface="Microsoft YaHei" pitchFamily="34" charset="-120"/>
-              </a:rPr>
-              <a:t>这四条是准确率 100% 的确定性校验，单条命中即高置信 → 直接 T1。仅命中供应商级行为信号（拆分 / 突增 / 多次命中）→ T2。</a:t>
+                  <a:srgbClr val="17313F"/>
+                </a:solidFill>
+                <a:latin typeface="Microsoft YaHei" pitchFamily="34" charset="0"/>
+                <a:ea typeface="Microsoft YaHei" pitchFamily="34" charset="-122"/>
+                <a:cs typeface="Microsoft YaHei" pitchFamily="34" charset="-120"/>
+              </a:rPr>
+              <a:t>回落到原有加权评分（供应商分 / 付款分 / 合理性），批量排序后取 Top K 复核。</a:t>
             </a:r>
             <a:endParaRPr lang="en-US" sz="1250" dirty="0"/>
           </a:p>
@@ -4387,7 +4656,7 @@
       </p:sp>
       <p:sp>
         <p:nvSpPr>
-          <p:cNvPr id="22" name="Text 20"/>
+          <p:cNvPr id="28" name="Text 26"/>
           <p:cNvSpPr/>
           <p:nvPr/>
         </p:nvSpPr>
@@ -4426,7 +4695,7 @@
       </p:sp>
       <p:sp>
         <p:nvSpPr>
-          <p:cNvPr id="23" name="Text 21"/>
+          <p:cNvPr id="29" name="Text 27"/>
           <p:cNvSpPr/>
           <p:nvPr/>
         </p:nvSpPr>

</xml_diff>